<commit_message>
Fix PPTX layout overlaps: stat boxes within slide, slide numbers clear of content
https://claude.ai/code/session_01Q3cKYa5ZXMJytcobrHSvzj
</commit_message>
<xml_diff>
--- a/assets/tick-pick-pitch.pptx
+++ b/assets/tick-pick-pitch.pptx
@@ -4379,7 +4379,7 @@
         </p:nvSpPr>
         <p:spPr>
           <a:xfrm>
-            <a:off x="914400" y="6309360"/>
+            <a:off x="914400" y="6035040"/>
             <a:ext cx="10360152" cy="365760"/>
           </a:xfrm>
           <a:prstGeom prst="rect">
@@ -8544,8 +8544,8 @@
         </p:nvSpPr>
         <p:spPr>
           <a:xfrm>
-            <a:off x="7955279" y="1508760"/>
-            <a:ext cx="2560320" cy="1737360"/>
+            <a:off x="7589520" y="1508760"/>
+            <a:ext cx="2194560" cy="1737360"/>
           </a:xfrm>
           <a:prstGeom prst="roundRect">
             <a:avLst/>
@@ -8589,8 +8589,8 @@
         </p:nvSpPr>
         <p:spPr>
           <a:xfrm>
-            <a:off x="7955279" y="1691640"/>
-            <a:ext cx="2560320" cy="822960"/>
+            <a:off x="7589520" y="1691640"/>
+            <a:ext cx="2194560" cy="822960"/>
           </a:xfrm>
           <a:prstGeom prst="rect">
             <a:avLst/>
@@ -8623,8 +8623,8 @@
         </p:nvSpPr>
         <p:spPr>
           <a:xfrm>
-            <a:off x="7955279" y="2606040"/>
-            <a:ext cx="2560320" cy="457200"/>
+            <a:off x="7589520" y="2606040"/>
+            <a:ext cx="2194560" cy="457200"/>
           </a:xfrm>
           <a:prstGeom prst="rect">
             <a:avLst/>
@@ -8657,8 +8657,8 @@
         </p:nvSpPr>
         <p:spPr>
           <a:xfrm>
-            <a:off x="10607040" y="1508760"/>
-            <a:ext cx="2560320" cy="1737360"/>
+            <a:off x="9966960" y="1508760"/>
+            <a:ext cx="2194560" cy="1737360"/>
           </a:xfrm>
           <a:prstGeom prst="roundRect">
             <a:avLst/>
@@ -8702,8 +8702,8 @@
         </p:nvSpPr>
         <p:spPr>
           <a:xfrm>
-            <a:off x="10607040" y="1691640"/>
-            <a:ext cx="2560320" cy="822960"/>
+            <a:off x="9966960" y="1691640"/>
+            <a:ext cx="2194560" cy="822960"/>
           </a:xfrm>
           <a:prstGeom prst="rect">
             <a:avLst/>
@@ -8736,8 +8736,8 @@
         </p:nvSpPr>
         <p:spPr>
           <a:xfrm>
-            <a:off x="10607040" y="2606040"/>
-            <a:ext cx="2560320" cy="457200"/>
+            <a:off x="9966960" y="2606040"/>
+            <a:ext cx="2194560" cy="457200"/>
           </a:xfrm>
           <a:prstGeom prst="rect">
             <a:avLst/>
@@ -8770,8 +8770,8 @@
         </p:nvSpPr>
         <p:spPr>
           <a:xfrm>
-            <a:off x="7955279" y="3520440"/>
-            <a:ext cx="2560320" cy="1737360"/>
+            <a:off x="7589520" y="3520440"/>
+            <a:ext cx="2194560" cy="1737360"/>
           </a:xfrm>
           <a:prstGeom prst="roundRect">
             <a:avLst/>
@@ -8815,8 +8815,8 @@
         </p:nvSpPr>
         <p:spPr>
           <a:xfrm>
-            <a:off x="7955279" y="3703320"/>
-            <a:ext cx="2560320" cy="822960"/>
+            <a:off x="7589520" y="3703320"/>
+            <a:ext cx="2194560" cy="822960"/>
           </a:xfrm>
           <a:prstGeom prst="rect">
             <a:avLst/>
@@ -8849,8 +8849,8 @@
         </p:nvSpPr>
         <p:spPr>
           <a:xfrm>
-            <a:off x="7955279" y="4617720"/>
-            <a:ext cx="2560320" cy="457200"/>
+            <a:off x="7589520" y="4617720"/>
+            <a:ext cx="2194560" cy="457200"/>
           </a:xfrm>
           <a:prstGeom prst="rect">
             <a:avLst/>
@@ -8883,8 +8883,8 @@
         </p:nvSpPr>
         <p:spPr>
           <a:xfrm>
-            <a:off x="10607040" y="3520440"/>
-            <a:ext cx="2560320" cy="1737360"/>
+            <a:off x="9966960" y="3520440"/>
+            <a:ext cx="2194560" cy="1737360"/>
           </a:xfrm>
           <a:prstGeom prst="roundRect">
             <a:avLst/>
@@ -8928,8 +8928,8 @@
         </p:nvSpPr>
         <p:spPr>
           <a:xfrm>
-            <a:off x="10607040" y="3703320"/>
-            <a:ext cx="2560320" cy="822960"/>
+            <a:off x="9966960" y="3703320"/>
+            <a:ext cx="2194560" cy="822960"/>
           </a:xfrm>
           <a:prstGeom prst="rect">
             <a:avLst/>
@@ -8962,8 +8962,8 @@
         </p:nvSpPr>
         <p:spPr>
           <a:xfrm>
-            <a:off x="10607040" y="4617720"/>
-            <a:ext cx="2560320" cy="457200"/>
+            <a:off x="9966960" y="4617720"/>
+            <a:ext cx="2194560" cy="457200"/>
           </a:xfrm>
           <a:prstGeom prst="rect">
             <a:avLst/>
@@ -8996,7 +8996,7 @@
         </p:nvSpPr>
         <p:spPr>
           <a:xfrm>
-            <a:off x="548640" y="6263640"/>
+            <a:off x="548640" y="5943600"/>
             <a:ext cx="11064240" cy="411480"/>
           </a:xfrm>
           <a:prstGeom prst="roundRect">
@@ -9039,7 +9039,7 @@
         </p:nvSpPr>
         <p:spPr>
           <a:xfrm>
-            <a:off x="548640" y="6309360"/>
+            <a:off x="548640" y="5989320"/>
             <a:ext cx="11064240" cy="365760"/>
           </a:xfrm>
           <a:prstGeom prst="rect">
@@ -15302,8 +15302,8 @@
         </p:nvSpPr>
         <p:spPr>
           <a:xfrm>
-            <a:off x="365760" y="5623560"/>
-            <a:ext cx="11457432" cy="1005840"/>
+            <a:off x="365760" y="5440680"/>
+            <a:ext cx="11457432" cy="914400"/>
           </a:xfrm>
           <a:prstGeom prst="roundRect">
             <a:avLst/>
@@ -15347,7 +15347,7 @@
         </p:nvSpPr>
         <p:spPr>
           <a:xfrm>
-            <a:off x="548640" y="5715000"/>
+            <a:off x="548640" y="5532120"/>
             <a:ext cx="10972800" cy="365760"/>
           </a:xfrm>
           <a:prstGeom prst="rect">
@@ -15381,7 +15381,7 @@
         </p:nvSpPr>
         <p:spPr>
           <a:xfrm>
-            <a:off x="548640" y="6080760"/>
+            <a:off x="548640" y="5897880"/>
             <a:ext cx="10972800" cy="411480"/>
           </a:xfrm>
           <a:prstGeom prst="rect">

</xml_diff>